<commit_message>
Update Scan2Twin PPTX: NVIDIA=green, OSS=blue
</commit_message>
<xml_diff>
--- a/scan2twin-architecture.pptx
+++ b/scan2twin-architecture.pptx
@@ -3333,7 +3333,7 @@
           </a:solidFill>
           <a:ln w="25400">
             <a:solidFill>
-              <a:srgbClr val="008AC8"/>
+              <a:srgbClr val="76B900"/>
             </a:solidFill>
           </a:ln>
         </p:spPr>
@@ -3385,10 +3385,10 @@
             <a:r>
               <a:rPr sz="1100" b="1">
                 <a:solidFill>
-                  <a:srgbClr val="008AC8"/>
-                </a:solidFill>
-              </a:rPr>
-              <a:t>🔵  NVIDIA</a:t>
+                  <a:srgbClr val="76B900"/>
+                </a:solidFill>
+              </a:rPr>
+              <a:t>🟢  NVIDIA</a:t>
             </a:r>
           </a:p>
         </p:txBody>
@@ -3570,7 +3570,7 @@
           </a:solidFill>
           <a:ln w="25400">
             <a:solidFill>
-              <a:srgbClr val="4CAF50"/>
+              <a:srgbClr val="008AC8"/>
             </a:solidFill>
           </a:ln>
         </p:spPr>
@@ -3622,10 +3622,10 @@
             <a:r>
               <a:rPr sz="1100" b="1">
                 <a:solidFill>
-                  <a:srgbClr val="4CAF50"/>
-                </a:solidFill>
-              </a:rPr>
-              <a:t>🟢  OSS</a:t>
+                  <a:srgbClr val="008AC8"/>
+                </a:solidFill>
+              </a:rPr>
+              <a:t>🔵  OSS</a:t>
             </a:r>
           </a:p>
         </p:txBody>
@@ -3981,7 +3981,7 @@
           </a:solidFill>
           <a:ln w="31750">
             <a:solidFill>
-              <a:srgbClr val="008AC8"/>
+              <a:srgbClr val="76B900"/>
             </a:solidFill>
           </a:ln>
         </p:spPr>
@@ -4033,7 +4033,7 @@
             <a:r>
               <a:rPr sz="900" b="1">
                 <a:solidFill>
-                  <a:srgbClr val="008AC8"/>
+                  <a:srgbClr val="76B900"/>
                 </a:solidFill>
               </a:rPr>
               <a:t>1
@@ -4096,7 +4096,7 @@
           </a:solidFill>
           <a:ln w="31750">
             <a:solidFill>
-              <a:srgbClr val="4CAF50"/>
+              <a:srgbClr val="008AC8"/>
             </a:solidFill>
           </a:ln>
         </p:spPr>
@@ -4148,7 +4148,7 @@
             <a:r>
               <a:rPr sz="900" b="1">
                 <a:solidFill>
-                  <a:srgbClr val="4CAF50"/>
+                  <a:srgbClr val="008AC8"/>
                 </a:solidFill>
               </a:rPr>
               <a:t>2
@@ -4327,7 +4327,7 @@
           </a:solidFill>
           <a:ln w="31750">
             <a:solidFill>
-              <a:srgbClr val="4CAF50"/>
+              <a:srgbClr val="008AC8"/>
             </a:solidFill>
           </a:ln>
         </p:spPr>
@@ -4379,7 +4379,7 @@
             <a:r>
               <a:rPr sz="900" b="1">
                 <a:solidFill>
-                  <a:srgbClr val="4CAF50"/>
+                  <a:srgbClr val="008AC8"/>
                 </a:solidFill>
               </a:rPr>
               <a:t>4
@@ -4443,7 +4443,7 @@
           </a:solidFill>
           <a:ln w="31750">
             <a:solidFill>
-              <a:srgbClr val="008AC8"/>
+              <a:srgbClr val="76B900"/>
             </a:solidFill>
           </a:ln>
         </p:spPr>
@@ -4495,7 +4495,7 @@
             <a:r>
               <a:rPr sz="900" b="1">
                 <a:solidFill>
-                  <a:srgbClr val="008AC8"/>
+                  <a:srgbClr val="76B900"/>
                 </a:solidFill>
               </a:rPr>
               <a:t>5
@@ -4559,7 +4559,7 @@
           </a:solidFill>
           <a:ln w="31750">
             <a:solidFill>
-              <a:srgbClr val="008AC8"/>
+              <a:srgbClr val="76B900"/>
             </a:solidFill>
           </a:ln>
         </p:spPr>
@@ -4611,7 +4611,7 @@
             <a:r>
               <a:rPr sz="900" b="1">
                 <a:solidFill>
-                  <a:srgbClr val="008AC8"/>
+                  <a:srgbClr val="76B900"/>
                 </a:solidFill>
               </a:rPr>
               <a:t>6
@@ -4834,7 +4834,7 @@
           </a:solidFill>
           <a:ln w="19050">
             <a:solidFill>
-              <a:srgbClr val="008AC8"/>
+              <a:srgbClr val="76B900"/>
             </a:solidFill>
           </a:ln>
         </p:spPr>
@@ -4886,7 +4886,7 @@
             <a:r>
               <a:rPr sz="700" b="0">
                 <a:solidFill>
-                  <a:srgbClr val="008AC8"/>
+                  <a:srgbClr val="76B900"/>
                 </a:solidFill>
               </a:rPr>
               <a:t>NVCF ingest endpoint</a:t>
@@ -4913,7 +4913,7 @@
           </a:solidFill>
           <a:ln w="19050">
             <a:solidFill>
-              <a:srgbClr val="4CAF50"/>
+              <a:srgbClr val="008AC8"/>
             </a:solidFill>
           </a:ln>
         </p:spPr>
@@ -4965,7 +4965,7 @@
             <a:r>
               <a:rPr sz="700" b="0">
                 <a:solidFill>
-                  <a:srgbClr val="4CAF50"/>
+                  <a:srgbClr val="008AC8"/>
                 </a:solidFill>
               </a:rPr>
               <a:t>open3d reader + noise filter + voxel downsample</a:t>
@@ -5105,7 +5105,7 @@
           </a:solidFill>
           <a:ln w="19050">
             <a:solidFill>
-              <a:srgbClr val="4CAF50"/>
+              <a:srgbClr val="008AC8"/>
             </a:solidFill>
           </a:ln>
         </p:spPr>
@@ -5157,7 +5157,7 @@
             <a:r>
               <a:rPr sz="700" b="0">
                 <a:solidFill>
-                  <a:srgbClr val="4CAF50"/>
+                  <a:srgbClr val="008AC8"/>
                 </a:solidFill>
               </a:rPr>
               <a:t>Euclidean cluster segmentation (default)</a:t>
@@ -5184,7 +5184,7 @@
           </a:solidFill>
           <a:ln w="19050">
             <a:solidFill>
-              <a:srgbClr val="4CAF50"/>
+              <a:srgbClr val="008AC8"/>
             </a:solidFill>
           </a:ln>
         </p:spPr>
@@ -5236,7 +5236,7 @@
             <a:r>
               <a:rPr sz="700" b="0">
                 <a:solidFill>
-                  <a:srgbClr val="4CAF50"/>
+                  <a:srgbClr val="008AC8"/>
                 </a:solidFill>
               </a:rPr>
               <a:t>DBSCAN (swappable via registry)</a:t>
@@ -5455,7 +5455,7 @@
           </a:solidFill>
           <a:ln w="19050">
             <a:solidFill>
-              <a:srgbClr val="008AC8"/>
+              <a:srgbClr val="76B900"/>
             </a:solidFill>
           </a:ln>
         </p:spPr>
@@ -5507,7 +5507,7 @@
             <a:r>
               <a:rPr sz="700" b="0">
                 <a:solidFill>
-                  <a:srgbClr val="008AC8"/>
+                  <a:srgbClr val="76B900"/>
                 </a:solidFill>
               </a:rPr>
               <a:t>NVCF inference endpoint wrapper</a:t>
@@ -5647,7 +5647,7 @@
           </a:solidFill>
           <a:ln w="19050">
             <a:solidFill>
-              <a:srgbClr val="4CAF50"/>
+              <a:srgbClr val="008AC8"/>
             </a:solidFill>
           </a:ln>
         </p:spPr>
@@ -5699,7 +5699,7 @@
             <a:r>
               <a:rPr sz="700" b="0">
                 <a:solidFill>
-                  <a:srgbClr val="4CAF50"/>
+                  <a:srgbClr val="008AC8"/>
                 </a:solidFill>
               </a:rPr>
               <a:t>open3d: Poisson/BPA mesh reconstruction</a:t>
@@ -5805,7 +5805,7 @@
           </a:solidFill>
           <a:ln w="19050">
             <a:solidFill>
-              <a:srgbClr val="008AC8"/>
+              <a:srgbClr val="76B900"/>
             </a:solidFill>
           </a:ln>
         </p:spPr>
@@ -5857,7 +5857,7 @@
             <a:r>
               <a:rPr sz="700" b="0">
                 <a:solidFill>
-                  <a:srgbClr val="008AC8"/>
+                  <a:srgbClr val="76B900"/>
                 </a:solidFill>
               </a:rPr>
               <a:t>OpenUSD SDK: prim assembly</a:t>
@@ -5997,7 +5997,7 @@
           </a:solidFill>
           <a:ln w="19050">
             <a:solidFill>
-              <a:srgbClr val="008AC8"/>
+              <a:srgbClr val="76B900"/>
             </a:solidFill>
           </a:ln>
         </p:spPr>
@@ -6049,7 +6049,7 @@
             <a:r>
               <a:rPr sz="700" b="0">
                 <a:solidFill>
-                  <a:srgbClr val="008AC8"/>
+                  <a:srgbClr val="76B900"/>
                 </a:solidFill>
               </a:rPr>
               <a:t>AI Material Agent (NVCF)</a:t>
@@ -6067,6 +6067,943 @@
           <a:xfrm>
             <a:off x="8153399" y="3803904"/>
             <a:ext cx="1798320" cy="384048"/>
+          </a:xfrm>
+          <a:prstGeom prst="rect">
+            <a:avLst/>
+          </a:prstGeom>
+          <a:solidFill>
+            <a:srgbClr val="16213E"/>
+          </a:solidFill>
+          <a:ln w="19050">
+            <a:solidFill>
+              <a:srgbClr val="76B900"/>
+            </a:solidFill>
+          </a:ln>
+        </p:spPr>
+        <p:style>
+          <a:lnRef idx="1">
+            <a:schemeClr val="accent1"/>
+          </a:lnRef>
+          <a:fillRef idx="3">
+            <a:schemeClr val="accent1"/>
+          </a:fillRef>
+          <a:effectRef idx="2">
+            <a:schemeClr val="accent1"/>
+          </a:effectRef>
+          <a:fontRef idx="minor">
+            <a:schemeClr val="lt1"/>
+          </a:fontRef>
+        </p:style>
+        <p:txBody>
+          <a:bodyPr rtlCol="0" anchor="ctr"/>
+          <a:lstStyle/>
+          <a:p>
+            <a:pPr algn="ctr"/>
+          </a:p>
+        </p:txBody>
+      </p:sp>
+      <p:sp>
+        <p:nvSpPr>
+          <p:cNvPr id="63" name="TextBox 62"/>
+          <p:cNvSpPr txBox="1"/>
+          <p:nvPr/>
+        </p:nvSpPr>
+        <p:spPr>
+          <a:xfrm>
+            <a:off x="8171687" y="3822191"/>
+            <a:ext cx="1780032" cy="347472"/>
+          </a:xfrm>
+          <a:prstGeom prst="rect">
+            <a:avLst/>
+          </a:prstGeom>
+          <a:noFill/>
+        </p:spPr>
+        <p:txBody>
+          <a:bodyPr wrap="square">
+            <a:spAutoFit/>
+          </a:bodyPr>
+          <a:lstStyle/>
+          <a:p>
+            <a:pPr algn="ctr"/>
+            <a:r>
+              <a:rPr sz="700" b="0">
+                <a:solidFill>
+                  <a:srgbClr val="76B900"/>
+                </a:solidFill>
+              </a:rPr>
+              <a:t>MDL material library</a:t>
+            </a:r>
+          </a:p>
+        </p:txBody>
+      </p:sp>
+      <p:sp>
+        <p:nvSpPr>
+          <p:cNvPr id="64" name="Rectangle 63"/>
+          <p:cNvSpPr/>
+          <p:nvPr/>
+        </p:nvSpPr>
+        <p:spPr>
+          <a:xfrm>
+            <a:off x="8153399" y="4242816"/>
+            <a:ext cx="1798320" cy="384048"/>
+          </a:xfrm>
+          <a:prstGeom prst="rect">
+            <a:avLst/>
+          </a:prstGeom>
+          <a:solidFill>
+            <a:srgbClr val="16213E"/>
+          </a:solidFill>
+          <a:ln w="19050">
+            <a:solidFill>
+              <a:srgbClr val="E58C1A"/>
+            </a:solidFill>
+          </a:ln>
+        </p:spPr>
+        <p:style>
+          <a:lnRef idx="1">
+            <a:schemeClr val="accent1"/>
+          </a:lnRef>
+          <a:fillRef idx="3">
+            <a:schemeClr val="accent1"/>
+          </a:fillRef>
+          <a:effectRef idx="2">
+            <a:schemeClr val="accent1"/>
+          </a:effectRef>
+          <a:fontRef idx="minor">
+            <a:schemeClr val="lt1"/>
+          </a:fontRef>
+        </p:style>
+        <p:txBody>
+          <a:bodyPr rtlCol="0" anchor="ctr"/>
+          <a:lstStyle/>
+          <a:p>
+            <a:pPr algn="ctr"/>
+          </a:p>
+        </p:txBody>
+      </p:sp>
+      <p:sp>
+        <p:nvSpPr>
+          <p:cNvPr id="65" name="TextBox 64"/>
+          <p:cNvSpPr txBox="1"/>
+          <p:nvPr/>
+        </p:nvSpPr>
+        <p:spPr>
+          <a:xfrm>
+            <a:off x="8171687" y="4261104"/>
+            <a:ext cx="1780032" cy="347472"/>
+          </a:xfrm>
+          <a:prstGeom prst="rect">
+            <a:avLst/>
+          </a:prstGeom>
+          <a:noFill/>
+        </p:spPr>
+        <p:txBody>
+          <a:bodyPr wrap="square">
+            <a:spAutoFit/>
+          </a:bodyPr>
+          <a:lstStyle/>
+          <a:p>
+            <a:pPr algn="ctr"/>
+            <a:r>
+              <a:rPr sz="700" b="0">
+                <a:solidFill>
+                  <a:srgbClr val="E58C1A"/>
+                </a:solidFill>
+              </a:rPr>
+              <a:t>Siemens DTC adapter</a:t>
+            </a:r>
+          </a:p>
+        </p:txBody>
+      </p:sp>
+      <p:sp>
+        <p:nvSpPr>
+          <p:cNvPr id="66" name="Rectangle 65"/>
+          <p:cNvSpPr/>
+          <p:nvPr/>
+        </p:nvSpPr>
+        <p:spPr>
+          <a:xfrm>
+            <a:off x="8153399" y="4681728"/>
+            <a:ext cx="1798320" cy="384048"/>
+          </a:xfrm>
+          <a:prstGeom prst="rect">
+            <a:avLst/>
+          </a:prstGeom>
+          <a:solidFill>
+            <a:srgbClr val="16213E"/>
+          </a:solidFill>
+          <a:ln w="19050">
+            <a:solidFill>
+              <a:srgbClr val="F5C518"/>
+            </a:solidFill>
+          </a:ln>
+        </p:spPr>
+        <p:style>
+          <a:lnRef idx="1">
+            <a:schemeClr val="accent1"/>
+          </a:lnRef>
+          <a:fillRef idx="3">
+            <a:schemeClr val="accent1"/>
+          </a:fillRef>
+          <a:effectRef idx="2">
+            <a:schemeClr val="accent1"/>
+          </a:effectRef>
+          <a:fontRef idx="minor">
+            <a:schemeClr val="lt1"/>
+          </a:fontRef>
+        </p:style>
+        <p:txBody>
+          <a:bodyPr rtlCol="0" anchor="ctr"/>
+          <a:lstStyle/>
+          <a:p>
+            <a:pPr algn="ctr"/>
+          </a:p>
+        </p:txBody>
+      </p:sp>
+      <p:sp>
+        <p:nvSpPr>
+          <p:cNvPr id="67" name="TextBox 66"/>
+          <p:cNvSpPr txBox="1"/>
+          <p:nvPr/>
+        </p:nvSpPr>
+        <p:spPr>
+          <a:xfrm>
+            <a:off x="8171687" y="4700016"/>
+            <a:ext cx="1780032" cy="347472"/>
+          </a:xfrm>
+          <a:prstGeom prst="rect">
+            <a:avLst/>
+          </a:prstGeom>
+          <a:noFill/>
+        </p:spPr>
+        <p:txBody>
+          <a:bodyPr wrap="square">
+            <a:spAutoFit/>
+          </a:bodyPr>
+          <a:lstStyle/>
+          <a:p>
+            <a:pPr algn="ctr"/>
+            <a:r>
+              <a:rPr sz="700" b="0">
+                <a:solidFill>
+                  <a:srgbClr val="F5C518"/>
+                </a:solidFill>
+              </a:rPr>
+              <a:t>physics property defaults sample</a:t>
+            </a:r>
+          </a:p>
+        </p:txBody>
+      </p:sp>
+      <p:sp>
+        <p:nvSpPr>
+          <p:cNvPr id="68" name="TextBox 67"/>
+          <p:cNvSpPr txBox="1"/>
+          <p:nvPr/>
+        </p:nvSpPr>
+        <p:spPr>
+          <a:xfrm>
+            <a:off x="10088879" y="3108960"/>
+            <a:ext cx="1889759" cy="228600"/>
+          </a:xfrm>
+          <a:prstGeom prst="rect">
+            <a:avLst/>
+          </a:prstGeom>
+          <a:noFill/>
+        </p:spPr>
+        <p:txBody>
+          <a:bodyPr wrap="square">
+            <a:spAutoFit/>
+          </a:bodyPr>
+          <a:lstStyle/>
+          <a:p>
+            <a:pPr algn="ctr"/>
+            <a:r>
+              <a:rPr sz="800" b="1">
+                <a:solidFill>
+                  <a:srgbClr val="AAAAAA"/>
+                </a:solidFill>
+              </a:rPr>
+              <a:t>Stage 6</a:t>
+            </a:r>
+          </a:p>
+        </p:txBody>
+      </p:sp>
+      <p:sp>
+        <p:nvSpPr>
+          <p:cNvPr id="69" name="Rectangle 68"/>
+          <p:cNvSpPr/>
+          <p:nvPr/>
+        </p:nvSpPr>
+        <p:spPr>
+          <a:xfrm>
+            <a:off x="10134599" y="3364991"/>
+            <a:ext cx="1798320" cy="384048"/>
+          </a:xfrm>
+          <a:prstGeom prst="rect">
+            <a:avLst/>
+          </a:prstGeom>
+          <a:solidFill>
+            <a:srgbClr val="16213E"/>
+          </a:solidFill>
+          <a:ln w="19050">
+            <a:solidFill>
+              <a:srgbClr val="76B900"/>
+            </a:solidFill>
+          </a:ln>
+        </p:spPr>
+        <p:style>
+          <a:lnRef idx="1">
+            <a:schemeClr val="accent1"/>
+          </a:lnRef>
+          <a:fillRef idx="3">
+            <a:schemeClr val="accent1"/>
+          </a:fillRef>
+          <a:effectRef idx="2">
+            <a:schemeClr val="accent1"/>
+          </a:effectRef>
+          <a:fontRef idx="minor">
+            <a:schemeClr val="lt1"/>
+          </a:fontRef>
+        </p:style>
+        <p:txBody>
+          <a:bodyPr rtlCol="0" anchor="ctr"/>
+          <a:lstStyle/>
+          <a:p>
+            <a:pPr algn="ctr"/>
+          </a:p>
+        </p:txBody>
+      </p:sp>
+      <p:sp>
+        <p:nvSpPr>
+          <p:cNvPr id="70" name="TextBox 69"/>
+          <p:cNvSpPr txBox="1"/>
+          <p:nvPr/>
+        </p:nvSpPr>
+        <p:spPr>
+          <a:xfrm>
+            <a:off x="10152887" y="3383279"/>
+            <a:ext cx="1780032" cy="347472"/>
+          </a:xfrm>
+          <a:prstGeom prst="rect">
+            <a:avLst/>
+          </a:prstGeom>
+          <a:noFill/>
+        </p:spPr>
+        <p:txBody>
+          <a:bodyPr wrap="square">
+            <a:spAutoFit/>
+          </a:bodyPr>
+          <a:lstStyle/>
+          <a:p>
+            <a:pPr algn="ctr"/>
+            <a:r>
+              <a:rPr sz="700" b="0">
+                <a:solidFill>
+                  <a:srgbClr val="76B900"/>
+                </a:solidFill>
+              </a:rPr>
+              <a:t>OpenUSD SDK: stage assembly</a:t>
+            </a:r>
+          </a:p>
+        </p:txBody>
+      </p:sp>
+      <p:sp>
+        <p:nvSpPr>
+          <p:cNvPr id="71" name="Rectangle 70"/>
+          <p:cNvSpPr/>
+          <p:nvPr/>
+        </p:nvSpPr>
+        <p:spPr>
+          <a:xfrm>
+            <a:off x="10134599" y="3803904"/>
+            <a:ext cx="1798320" cy="384048"/>
+          </a:xfrm>
+          <a:prstGeom prst="rect">
+            <a:avLst/>
+          </a:prstGeom>
+          <a:solidFill>
+            <a:srgbClr val="16213E"/>
+          </a:solidFill>
+          <a:ln w="19050">
+            <a:solidFill>
+              <a:srgbClr val="76B900"/>
+            </a:solidFill>
+          </a:ln>
+        </p:spPr>
+        <p:style>
+          <a:lnRef idx="1">
+            <a:schemeClr val="accent1"/>
+          </a:lnRef>
+          <a:fillRef idx="3">
+            <a:schemeClr val="accent1"/>
+          </a:fillRef>
+          <a:effectRef idx="2">
+            <a:schemeClr val="accent1"/>
+          </a:effectRef>
+          <a:fontRef idx="minor">
+            <a:schemeClr val="lt1"/>
+          </a:fontRef>
+        </p:style>
+        <p:txBody>
+          <a:bodyPr rtlCol="0" anchor="ctr"/>
+          <a:lstStyle/>
+          <a:p>
+            <a:pPr algn="ctr"/>
+          </a:p>
+        </p:txBody>
+      </p:sp>
+      <p:sp>
+        <p:nvSpPr>
+          <p:cNvPr id="72" name="TextBox 71"/>
+          <p:cNvSpPr txBox="1"/>
+          <p:nvPr/>
+        </p:nvSpPr>
+        <p:spPr>
+          <a:xfrm>
+            <a:off x="10152887" y="3822191"/>
+            <a:ext cx="1780032" cy="347472"/>
+          </a:xfrm>
+          <a:prstGeom prst="rect">
+            <a:avLst/>
+          </a:prstGeom>
+          <a:noFill/>
+        </p:spPr>
+        <p:txBody>
+          <a:bodyPr wrap="square">
+            <a:spAutoFit/>
+          </a:bodyPr>
+          <a:lstStyle/>
+          <a:p>
+            <a:pPr algn="ctr"/>
+            <a:r>
+              <a:rPr sz="700" b="0">
+                <a:solidFill>
+                  <a:srgbClr val="76B900"/>
+                </a:solidFill>
+              </a:rPr>
+              <a:t>SimReady validator (standalone)</a:t>
+            </a:r>
+          </a:p>
+        </p:txBody>
+      </p:sp>
+      <p:sp>
+        <p:nvSpPr>
+          <p:cNvPr id="73" name="Rectangle 72"/>
+          <p:cNvSpPr/>
+          <p:nvPr/>
+        </p:nvSpPr>
+        <p:spPr>
+          <a:xfrm>
+            <a:off x="10134599" y="4242816"/>
+            <a:ext cx="1798320" cy="384048"/>
+          </a:xfrm>
+          <a:prstGeom prst="rect">
+            <a:avLst/>
+          </a:prstGeom>
+          <a:solidFill>
+            <a:srgbClr val="16213E"/>
+          </a:solidFill>
+          <a:ln w="19050">
+            <a:solidFill>
+              <a:srgbClr val="76B900"/>
+            </a:solidFill>
+          </a:ln>
+        </p:spPr>
+        <p:style>
+          <a:lnRef idx="1">
+            <a:schemeClr val="accent1"/>
+          </a:lnRef>
+          <a:fillRef idx="3">
+            <a:schemeClr val="accent1"/>
+          </a:fillRef>
+          <a:effectRef idx="2">
+            <a:schemeClr val="accent1"/>
+          </a:effectRef>
+          <a:fontRef idx="minor">
+            <a:schemeClr val="lt1"/>
+          </a:fontRef>
+        </p:style>
+        <p:txBody>
+          <a:bodyPr rtlCol="0" anchor="ctr"/>
+          <a:lstStyle/>
+          <a:p>
+            <a:pPr algn="ctr"/>
+          </a:p>
+        </p:txBody>
+      </p:sp>
+      <p:sp>
+        <p:nvSpPr>
+          <p:cNvPr id="74" name="TextBox 73"/>
+          <p:cNvSpPr txBox="1"/>
+          <p:nvPr/>
+        </p:nvSpPr>
+        <p:spPr>
+          <a:xfrm>
+            <a:off x="10152887" y="4261104"/>
+            <a:ext cx="1780032" cy="347472"/>
+          </a:xfrm>
+          <a:prstGeom prst="rect">
+            <a:avLst/>
+          </a:prstGeom>
+          <a:noFill/>
+        </p:spPr>
+        <p:txBody>
+          <a:bodyPr wrap="square">
+            <a:spAutoFit/>
+          </a:bodyPr>
+          <a:lstStyle/>
+          <a:p>
+            <a:pPr algn="ctr"/>
+            <a:r>
+              <a:rPr sz="700" b="0">
+                <a:solidFill>
+                  <a:srgbClr val="76B900"/>
+                </a:solidFill>
+              </a:rPr>
+              <a:t>ovRTX render validation</a:t>
+            </a:r>
+          </a:p>
+        </p:txBody>
+      </p:sp>
+      <p:sp>
+        <p:nvSpPr>
+          <p:cNvPr id="75" name="Rectangle 74"/>
+          <p:cNvSpPr/>
+          <p:nvPr/>
+        </p:nvSpPr>
+        <p:spPr>
+          <a:xfrm>
+            <a:off x="10134599" y="4681728"/>
+            <a:ext cx="1798320" cy="384048"/>
+          </a:xfrm>
+          <a:prstGeom prst="rect">
+            <a:avLst/>
+          </a:prstGeom>
+          <a:solidFill>
+            <a:srgbClr val="16213E"/>
+          </a:solidFill>
+          <a:ln w="19050">
+            <a:solidFill>
+              <a:srgbClr val="E58C1A"/>
+            </a:solidFill>
+          </a:ln>
+        </p:spPr>
+        <p:style>
+          <a:lnRef idx="1">
+            <a:schemeClr val="accent1"/>
+          </a:lnRef>
+          <a:fillRef idx="3">
+            <a:schemeClr val="accent1"/>
+          </a:fillRef>
+          <a:effectRef idx="2">
+            <a:schemeClr val="accent1"/>
+          </a:effectRef>
+          <a:fontRef idx="minor">
+            <a:schemeClr val="lt1"/>
+          </a:fontRef>
+        </p:style>
+        <p:txBody>
+          <a:bodyPr rtlCol="0" anchor="ctr"/>
+          <a:lstStyle/>
+          <a:p>
+            <a:pPr algn="ctr"/>
+          </a:p>
+        </p:txBody>
+      </p:sp>
+      <p:sp>
+        <p:nvSpPr>
+          <p:cNvPr id="76" name="TextBox 75"/>
+          <p:cNvSpPr txBox="1"/>
+          <p:nvPr/>
+        </p:nvSpPr>
+        <p:spPr>
+          <a:xfrm>
+            <a:off x="10152887" y="4700016"/>
+            <a:ext cx="1780032" cy="347472"/>
+          </a:xfrm>
+          <a:prstGeom prst="rect">
+            <a:avLst/>
+          </a:prstGeom>
+          <a:noFill/>
+        </p:spPr>
+        <p:txBody>
+          <a:bodyPr wrap="square">
+            <a:spAutoFit/>
+          </a:bodyPr>
+          <a:lstStyle/>
+          <a:p>
+            <a:pPr algn="ctr"/>
+            <a:r>
+              <a:rPr sz="700" b="0">
+                <a:solidFill>
+                  <a:srgbClr val="E58C1A"/>
+                </a:solidFill>
+              </a:rPr>
+              <a:t>Siemens DTC export adapter</a:t>
+            </a:r>
+          </a:p>
+        </p:txBody>
+      </p:sp>
+      <p:sp>
+        <p:nvSpPr>
+          <p:cNvPr id="77" name="Rectangle 76"/>
+          <p:cNvSpPr/>
+          <p:nvPr/>
+        </p:nvSpPr>
+        <p:spPr>
+          <a:xfrm>
+            <a:off x="10134599" y="5120640"/>
+            <a:ext cx="1798320" cy="384048"/>
+          </a:xfrm>
+          <a:prstGeom prst="rect">
+            <a:avLst/>
+          </a:prstGeom>
+          <a:solidFill>
+            <a:srgbClr val="16213E"/>
+          </a:solidFill>
+          <a:ln w="19050">
+            <a:solidFill>
+              <a:srgbClr val="F5C518"/>
+            </a:solidFill>
+          </a:ln>
+        </p:spPr>
+        <p:style>
+          <a:lnRef idx="1">
+            <a:schemeClr val="accent1"/>
+          </a:lnRef>
+          <a:fillRef idx="3">
+            <a:schemeClr val="accent1"/>
+          </a:fillRef>
+          <a:effectRef idx="2">
+            <a:schemeClr val="accent1"/>
+          </a:effectRef>
+          <a:fontRef idx="minor">
+            <a:schemeClr val="lt1"/>
+          </a:fontRef>
+        </p:style>
+        <p:txBody>
+          <a:bodyPr rtlCol="0" anchor="ctr"/>
+          <a:lstStyle/>
+          <a:p>
+            <a:pPr algn="ctr"/>
+          </a:p>
+        </p:txBody>
+      </p:sp>
+      <p:sp>
+        <p:nvSpPr>
+          <p:cNvPr id="78" name="TextBox 77"/>
+          <p:cNvSpPr txBox="1"/>
+          <p:nvPr/>
+        </p:nvSpPr>
+        <p:spPr>
+          <a:xfrm>
+            <a:off x="10152887" y="5138928"/>
+            <a:ext cx="1780032" cy="347472"/>
+          </a:xfrm>
+          <a:prstGeom prst="rect">
+            <a:avLst/>
+          </a:prstGeom>
+          <a:noFill/>
+        </p:spPr>
+        <p:txBody>
+          <a:bodyPr wrap="square">
+            <a:spAutoFit/>
+          </a:bodyPr>
+          <a:lstStyle/>
+          <a:p>
+            <a:pPr algn="ctr"/>
+            <a:r>
+              <a:rPr sz="700" b="0">
+                <a:solidFill>
+                  <a:srgbClr val="F5C518"/>
+                </a:solidFill>
+              </a:rPr>
+              <a:t>USD output writer sample</a:t>
+            </a:r>
+          </a:p>
+        </p:txBody>
+      </p:sp>
+      <p:sp>
+        <p:nvSpPr>
+          <p:cNvPr id="79" name="TextBox 78"/>
+          <p:cNvSpPr txBox="1"/>
+          <p:nvPr/>
+        </p:nvSpPr>
+        <p:spPr>
+          <a:xfrm>
+            <a:off x="182880" y="6400800"/>
+            <a:ext cx="731520" cy="320040"/>
+          </a:xfrm>
+          <a:prstGeom prst="rect">
+            <a:avLst/>
+          </a:prstGeom>
+          <a:noFill/>
+        </p:spPr>
+        <p:txBody>
+          <a:bodyPr wrap="square">
+            <a:spAutoFit/>
+          </a:bodyPr>
+          <a:lstStyle/>
+          <a:p>
+            <a:pPr algn="l"/>
+            <a:r>
+              <a:rPr sz="900" b="1">
+                <a:solidFill>
+                  <a:srgbClr val="AAAAAA"/>
+                </a:solidFill>
+              </a:rPr>
+              <a:t>Legend:</a:t>
+            </a:r>
+          </a:p>
+        </p:txBody>
+      </p:sp>
+      <p:sp>
+        <p:nvSpPr>
+          <p:cNvPr id="80" name="Rectangle 79"/>
+          <p:cNvSpPr/>
+          <p:nvPr/>
+        </p:nvSpPr>
+        <p:spPr>
+          <a:xfrm>
+            <a:off x="914400" y="6400800"/>
+            <a:ext cx="1554480" cy="274320"/>
+          </a:xfrm>
+          <a:prstGeom prst="rect">
+            <a:avLst/>
+          </a:prstGeom>
+          <a:solidFill>
+            <a:srgbClr val="16213E"/>
+          </a:solidFill>
+          <a:ln w="19050">
+            <a:solidFill>
+              <a:srgbClr val="76B900"/>
+            </a:solidFill>
+          </a:ln>
+        </p:spPr>
+        <p:style>
+          <a:lnRef idx="1">
+            <a:schemeClr val="accent1"/>
+          </a:lnRef>
+          <a:fillRef idx="3">
+            <a:schemeClr val="accent1"/>
+          </a:fillRef>
+          <a:effectRef idx="2">
+            <a:schemeClr val="accent1"/>
+          </a:effectRef>
+          <a:fontRef idx="minor">
+            <a:schemeClr val="lt1"/>
+          </a:fontRef>
+        </p:style>
+        <p:txBody>
+          <a:bodyPr rtlCol="0" anchor="ctr"/>
+          <a:lstStyle/>
+          <a:p>
+            <a:pPr algn="ctr"/>
+          </a:p>
+        </p:txBody>
+      </p:sp>
+      <p:sp>
+        <p:nvSpPr>
+          <p:cNvPr id="81" name="TextBox 80"/>
+          <p:cNvSpPr txBox="1"/>
+          <p:nvPr/>
+        </p:nvSpPr>
+        <p:spPr>
+          <a:xfrm>
+            <a:off x="960120" y="6419088"/>
+            <a:ext cx="1463040" cy="237744"/>
+          </a:xfrm>
+          <a:prstGeom prst="rect">
+            <a:avLst/>
+          </a:prstGeom>
+          <a:noFill/>
+        </p:spPr>
+        <p:txBody>
+          <a:bodyPr wrap="square">
+            <a:spAutoFit/>
+          </a:bodyPr>
+          <a:lstStyle/>
+          <a:p>
+            <a:pPr algn="ctr"/>
+            <a:r>
+              <a:rPr sz="800" b="1">
+                <a:solidFill>
+                  <a:srgbClr val="76B900"/>
+                </a:solidFill>
+              </a:rPr>
+              <a:t>🟢  NVIDIA</a:t>
+            </a:r>
+          </a:p>
+        </p:txBody>
+      </p:sp>
+      <p:sp>
+        <p:nvSpPr>
+          <p:cNvPr id="82" name="Rectangle 81"/>
+          <p:cNvSpPr/>
+          <p:nvPr/>
+        </p:nvSpPr>
+        <p:spPr>
+          <a:xfrm>
+            <a:off x="2743200" y="6400800"/>
+            <a:ext cx="1554480" cy="274320"/>
+          </a:xfrm>
+          <a:prstGeom prst="rect">
+            <a:avLst/>
+          </a:prstGeom>
+          <a:solidFill>
+            <a:srgbClr val="16213E"/>
+          </a:solidFill>
+          <a:ln w="19050">
+            <a:solidFill>
+              <a:srgbClr val="E54B4B"/>
+            </a:solidFill>
+          </a:ln>
+        </p:spPr>
+        <p:style>
+          <a:lnRef idx="1">
+            <a:schemeClr val="accent1"/>
+          </a:lnRef>
+          <a:fillRef idx="3">
+            <a:schemeClr val="accent1"/>
+          </a:fillRef>
+          <a:effectRef idx="2">
+            <a:schemeClr val="accent1"/>
+          </a:effectRef>
+          <a:fontRef idx="minor">
+            <a:schemeClr val="lt1"/>
+          </a:fontRef>
+        </p:style>
+        <p:txBody>
+          <a:bodyPr rtlCol="0" anchor="ctr"/>
+          <a:lstStyle/>
+          <a:p>
+            <a:pPr algn="ctr"/>
+          </a:p>
+        </p:txBody>
+      </p:sp>
+      <p:sp>
+        <p:nvSpPr>
+          <p:cNvPr id="83" name="TextBox 82"/>
+          <p:cNvSpPr txBox="1"/>
+          <p:nvPr/>
+        </p:nvSpPr>
+        <p:spPr>
+          <a:xfrm>
+            <a:off x="2788920" y="6419088"/>
+            <a:ext cx="1463040" cy="237744"/>
+          </a:xfrm>
+          <a:prstGeom prst="rect">
+            <a:avLst/>
+          </a:prstGeom>
+          <a:noFill/>
+        </p:spPr>
+        <p:txBody>
+          <a:bodyPr wrap="square">
+            <a:spAutoFit/>
+          </a:bodyPr>
+          <a:lstStyle/>
+          <a:p>
+            <a:pPr algn="ctr"/>
+            <a:r>
+              <a:rPr sz="800" b="1">
+                <a:solidFill>
+                  <a:srgbClr val="E54B4B"/>
+                </a:solidFill>
+              </a:rPr>
+              <a:t>🔴  Physna</a:t>
+            </a:r>
+          </a:p>
+        </p:txBody>
+      </p:sp>
+      <p:sp>
+        <p:nvSpPr>
+          <p:cNvPr id="84" name="Rectangle 83"/>
+          <p:cNvSpPr/>
+          <p:nvPr/>
+        </p:nvSpPr>
+        <p:spPr>
+          <a:xfrm>
+            <a:off x="4572000" y="6400800"/>
+            <a:ext cx="1554480" cy="274320"/>
+          </a:xfrm>
+          <a:prstGeom prst="rect">
+            <a:avLst/>
+          </a:prstGeom>
+          <a:solidFill>
+            <a:srgbClr val="16213E"/>
+          </a:solidFill>
+          <a:ln w="19050">
+            <a:solidFill>
+              <a:srgbClr val="E58C1A"/>
+            </a:solidFill>
+          </a:ln>
+        </p:spPr>
+        <p:style>
+          <a:lnRef idx="1">
+            <a:schemeClr val="accent1"/>
+          </a:lnRef>
+          <a:fillRef idx="3">
+            <a:schemeClr val="accent1"/>
+          </a:fillRef>
+          <a:effectRef idx="2">
+            <a:schemeClr val="accent1"/>
+          </a:effectRef>
+          <a:fontRef idx="minor">
+            <a:schemeClr val="lt1"/>
+          </a:fontRef>
+        </p:style>
+        <p:txBody>
+          <a:bodyPr rtlCol="0" anchor="ctr"/>
+          <a:lstStyle/>
+          <a:p>
+            <a:pPr algn="ctr"/>
+          </a:p>
+        </p:txBody>
+      </p:sp>
+      <p:sp>
+        <p:nvSpPr>
+          <p:cNvPr id="85" name="TextBox 84"/>
+          <p:cNvSpPr txBox="1"/>
+          <p:nvPr/>
+        </p:nvSpPr>
+        <p:spPr>
+          <a:xfrm>
+            <a:off x="4617720" y="6419088"/>
+            <a:ext cx="1463040" cy="237744"/>
+          </a:xfrm>
+          <a:prstGeom prst="rect">
+            <a:avLst/>
+          </a:prstGeom>
+          <a:noFill/>
+        </p:spPr>
+        <p:txBody>
+          <a:bodyPr wrap="square">
+            <a:spAutoFit/>
+          </a:bodyPr>
+          <a:lstStyle/>
+          <a:p>
+            <a:pPr algn="ctr"/>
+            <a:r>
+              <a:rPr sz="800" b="1">
+                <a:solidFill>
+                  <a:srgbClr val="E58C1A"/>
+                </a:solidFill>
+              </a:rPr>
+              <a:t>🟠  Siemens</a:t>
+            </a:r>
+          </a:p>
+        </p:txBody>
+      </p:sp>
+      <p:sp>
+        <p:nvSpPr>
+          <p:cNvPr id="86" name="Rectangle 85"/>
+          <p:cNvSpPr/>
+          <p:nvPr/>
+        </p:nvSpPr>
+        <p:spPr>
+          <a:xfrm>
+            <a:off x="6400800" y="6400800"/>
+            <a:ext cx="1554480" cy="274320"/>
           </a:xfrm>
           <a:prstGeom prst="rect">
             <a:avLst/>
@@ -6104,943 +7041,6 @@
       </p:sp>
       <p:sp>
         <p:nvSpPr>
-          <p:cNvPr id="63" name="TextBox 62"/>
-          <p:cNvSpPr txBox="1"/>
-          <p:nvPr/>
-        </p:nvSpPr>
-        <p:spPr>
-          <a:xfrm>
-            <a:off x="8171687" y="3822191"/>
-            <a:ext cx="1780032" cy="347472"/>
-          </a:xfrm>
-          <a:prstGeom prst="rect">
-            <a:avLst/>
-          </a:prstGeom>
-          <a:noFill/>
-        </p:spPr>
-        <p:txBody>
-          <a:bodyPr wrap="square">
-            <a:spAutoFit/>
-          </a:bodyPr>
-          <a:lstStyle/>
-          <a:p>
-            <a:pPr algn="ctr"/>
-            <a:r>
-              <a:rPr sz="700" b="0">
-                <a:solidFill>
-                  <a:srgbClr val="008AC8"/>
-                </a:solidFill>
-              </a:rPr>
-              <a:t>MDL material library</a:t>
-            </a:r>
-          </a:p>
-        </p:txBody>
-      </p:sp>
-      <p:sp>
-        <p:nvSpPr>
-          <p:cNvPr id="64" name="Rectangle 63"/>
-          <p:cNvSpPr/>
-          <p:nvPr/>
-        </p:nvSpPr>
-        <p:spPr>
-          <a:xfrm>
-            <a:off x="8153399" y="4242816"/>
-            <a:ext cx="1798320" cy="384048"/>
-          </a:xfrm>
-          <a:prstGeom prst="rect">
-            <a:avLst/>
-          </a:prstGeom>
-          <a:solidFill>
-            <a:srgbClr val="16213E"/>
-          </a:solidFill>
-          <a:ln w="19050">
-            <a:solidFill>
-              <a:srgbClr val="E58C1A"/>
-            </a:solidFill>
-          </a:ln>
-        </p:spPr>
-        <p:style>
-          <a:lnRef idx="1">
-            <a:schemeClr val="accent1"/>
-          </a:lnRef>
-          <a:fillRef idx="3">
-            <a:schemeClr val="accent1"/>
-          </a:fillRef>
-          <a:effectRef idx="2">
-            <a:schemeClr val="accent1"/>
-          </a:effectRef>
-          <a:fontRef idx="minor">
-            <a:schemeClr val="lt1"/>
-          </a:fontRef>
-        </p:style>
-        <p:txBody>
-          <a:bodyPr rtlCol="0" anchor="ctr"/>
-          <a:lstStyle/>
-          <a:p>
-            <a:pPr algn="ctr"/>
-          </a:p>
-        </p:txBody>
-      </p:sp>
-      <p:sp>
-        <p:nvSpPr>
-          <p:cNvPr id="65" name="TextBox 64"/>
-          <p:cNvSpPr txBox="1"/>
-          <p:nvPr/>
-        </p:nvSpPr>
-        <p:spPr>
-          <a:xfrm>
-            <a:off x="8171687" y="4261104"/>
-            <a:ext cx="1780032" cy="347472"/>
-          </a:xfrm>
-          <a:prstGeom prst="rect">
-            <a:avLst/>
-          </a:prstGeom>
-          <a:noFill/>
-        </p:spPr>
-        <p:txBody>
-          <a:bodyPr wrap="square">
-            <a:spAutoFit/>
-          </a:bodyPr>
-          <a:lstStyle/>
-          <a:p>
-            <a:pPr algn="ctr"/>
-            <a:r>
-              <a:rPr sz="700" b="0">
-                <a:solidFill>
-                  <a:srgbClr val="E58C1A"/>
-                </a:solidFill>
-              </a:rPr>
-              <a:t>Siemens DTC adapter</a:t>
-            </a:r>
-          </a:p>
-        </p:txBody>
-      </p:sp>
-      <p:sp>
-        <p:nvSpPr>
-          <p:cNvPr id="66" name="Rectangle 65"/>
-          <p:cNvSpPr/>
-          <p:nvPr/>
-        </p:nvSpPr>
-        <p:spPr>
-          <a:xfrm>
-            <a:off x="8153399" y="4681728"/>
-            <a:ext cx="1798320" cy="384048"/>
-          </a:xfrm>
-          <a:prstGeom prst="rect">
-            <a:avLst/>
-          </a:prstGeom>
-          <a:solidFill>
-            <a:srgbClr val="16213E"/>
-          </a:solidFill>
-          <a:ln w="19050">
-            <a:solidFill>
-              <a:srgbClr val="F5C518"/>
-            </a:solidFill>
-          </a:ln>
-        </p:spPr>
-        <p:style>
-          <a:lnRef idx="1">
-            <a:schemeClr val="accent1"/>
-          </a:lnRef>
-          <a:fillRef idx="3">
-            <a:schemeClr val="accent1"/>
-          </a:fillRef>
-          <a:effectRef idx="2">
-            <a:schemeClr val="accent1"/>
-          </a:effectRef>
-          <a:fontRef idx="minor">
-            <a:schemeClr val="lt1"/>
-          </a:fontRef>
-        </p:style>
-        <p:txBody>
-          <a:bodyPr rtlCol="0" anchor="ctr"/>
-          <a:lstStyle/>
-          <a:p>
-            <a:pPr algn="ctr"/>
-          </a:p>
-        </p:txBody>
-      </p:sp>
-      <p:sp>
-        <p:nvSpPr>
-          <p:cNvPr id="67" name="TextBox 66"/>
-          <p:cNvSpPr txBox="1"/>
-          <p:nvPr/>
-        </p:nvSpPr>
-        <p:spPr>
-          <a:xfrm>
-            <a:off x="8171687" y="4700016"/>
-            <a:ext cx="1780032" cy="347472"/>
-          </a:xfrm>
-          <a:prstGeom prst="rect">
-            <a:avLst/>
-          </a:prstGeom>
-          <a:noFill/>
-        </p:spPr>
-        <p:txBody>
-          <a:bodyPr wrap="square">
-            <a:spAutoFit/>
-          </a:bodyPr>
-          <a:lstStyle/>
-          <a:p>
-            <a:pPr algn="ctr"/>
-            <a:r>
-              <a:rPr sz="700" b="0">
-                <a:solidFill>
-                  <a:srgbClr val="F5C518"/>
-                </a:solidFill>
-              </a:rPr>
-              <a:t>physics property defaults sample</a:t>
-            </a:r>
-          </a:p>
-        </p:txBody>
-      </p:sp>
-      <p:sp>
-        <p:nvSpPr>
-          <p:cNvPr id="68" name="TextBox 67"/>
-          <p:cNvSpPr txBox="1"/>
-          <p:nvPr/>
-        </p:nvSpPr>
-        <p:spPr>
-          <a:xfrm>
-            <a:off x="10088879" y="3108960"/>
-            <a:ext cx="1889759" cy="228600"/>
-          </a:xfrm>
-          <a:prstGeom prst="rect">
-            <a:avLst/>
-          </a:prstGeom>
-          <a:noFill/>
-        </p:spPr>
-        <p:txBody>
-          <a:bodyPr wrap="square">
-            <a:spAutoFit/>
-          </a:bodyPr>
-          <a:lstStyle/>
-          <a:p>
-            <a:pPr algn="ctr"/>
-            <a:r>
-              <a:rPr sz="800" b="1">
-                <a:solidFill>
-                  <a:srgbClr val="AAAAAA"/>
-                </a:solidFill>
-              </a:rPr>
-              <a:t>Stage 6</a:t>
-            </a:r>
-          </a:p>
-        </p:txBody>
-      </p:sp>
-      <p:sp>
-        <p:nvSpPr>
-          <p:cNvPr id="69" name="Rectangle 68"/>
-          <p:cNvSpPr/>
-          <p:nvPr/>
-        </p:nvSpPr>
-        <p:spPr>
-          <a:xfrm>
-            <a:off x="10134599" y="3364991"/>
-            <a:ext cx="1798320" cy="384048"/>
-          </a:xfrm>
-          <a:prstGeom prst="rect">
-            <a:avLst/>
-          </a:prstGeom>
-          <a:solidFill>
-            <a:srgbClr val="16213E"/>
-          </a:solidFill>
-          <a:ln w="19050">
-            <a:solidFill>
-              <a:srgbClr val="008AC8"/>
-            </a:solidFill>
-          </a:ln>
-        </p:spPr>
-        <p:style>
-          <a:lnRef idx="1">
-            <a:schemeClr val="accent1"/>
-          </a:lnRef>
-          <a:fillRef idx="3">
-            <a:schemeClr val="accent1"/>
-          </a:fillRef>
-          <a:effectRef idx="2">
-            <a:schemeClr val="accent1"/>
-          </a:effectRef>
-          <a:fontRef idx="minor">
-            <a:schemeClr val="lt1"/>
-          </a:fontRef>
-        </p:style>
-        <p:txBody>
-          <a:bodyPr rtlCol="0" anchor="ctr"/>
-          <a:lstStyle/>
-          <a:p>
-            <a:pPr algn="ctr"/>
-          </a:p>
-        </p:txBody>
-      </p:sp>
-      <p:sp>
-        <p:nvSpPr>
-          <p:cNvPr id="70" name="TextBox 69"/>
-          <p:cNvSpPr txBox="1"/>
-          <p:nvPr/>
-        </p:nvSpPr>
-        <p:spPr>
-          <a:xfrm>
-            <a:off x="10152887" y="3383279"/>
-            <a:ext cx="1780032" cy="347472"/>
-          </a:xfrm>
-          <a:prstGeom prst="rect">
-            <a:avLst/>
-          </a:prstGeom>
-          <a:noFill/>
-        </p:spPr>
-        <p:txBody>
-          <a:bodyPr wrap="square">
-            <a:spAutoFit/>
-          </a:bodyPr>
-          <a:lstStyle/>
-          <a:p>
-            <a:pPr algn="ctr"/>
-            <a:r>
-              <a:rPr sz="700" b="0">
-                <a:solidFill>
-                  <a:srgbClr val="008AC8"/>
-                </a:solidFill>
-              </a:rPr>
-              <a:t>OpenUSD SDK: stage assembly</a:t>
-            </a:r>
-          </a:p>
-        </p:txBody>
-      </p:sp>
-      <p:sp>
-        <p:nvSpPr>
-          <p:cNvPr id="71" name="Rectangle 70"/>
-          <p:cNvSpPr/>
-          <p:nvPr/>
-        </p:nvSpPr>
-        <p:spPr>
-          <a:xfrm>
-            <a:off x="10134599" y="3803904"/>
-            <a:ext cx="1798320" cy="384048"/>
-          </a:xfrm>
-          <a:prstGeom prst="rect">
-            <a:avLst/>
-          </a:prstGeom>
-          <a:solidFill>
-            <a:srgbClr val="16213E"/>
-          </a:solidFill>
-          <a:ln w="19050">
-            <a:solidFill>
-              <a:srgbClr val="008AC8"/>
-            </a:solidFill>
-          </a:ln>
-        </p:spPr>
-        <p:style>
-          <a:lnRef idx="1">
-            <a:schemeClr val="accent1"/>
-          </a:lnRef>
-          <a:fillRef idx="3">
-            <a:schemeClr val="accent1"/>
-          </a:fillRef>
-          <a:effectRef idx="2">
-            <a:schemeClr val="accent1"/>
-          </a:effectRef>
-          <a:fontRef idx="minor">
-            <a:schemeClr val="lt1"/>
-          </a:fontRef>
-        </p:style>
-        <p:txBody>
-          <a:bodyPr rtlCol="0" anchor="ctr"/>
-          <a:lstStyle/>
-          <a:p>
-            <a:pPr algn="ctr"/>
-          </a:p>
-        </p:txBody>
-      </p:sp>
-      <p:sp>
-        <p:nvSpPr>
-          <p:cNvPr id="72" name="TextBox 71"/>
-          <p:cNvSpPr txBox="1"/>
-          <p:nvPr/>
-        </p:nvSpPr>
-        <p:spPr>
-          <a:xfrm>
-            <a:off x="10152887" y="3822191"/>
-            <a:ext cx="1780032" cy="347472"/>
-          </a:xfrm>
-          <a:prstGeom prst="rect">
-            <a:avLst/>
-          </a:prstGeom>
-          <a:noFill/>
-        </p:spPr>
-        <p:txBody>
-          <a:bodyPr wrap="square">
-            <a:spAutoFit/>
-          </a:bodyPr>
-          <a:lstStyle/>
-          <a:p>
-            <a:pPr algn="ctr"/>
-            <a:r>
-              <a:rPr sz="700" b="0">
-                <a:solidFill>
-                  <a:srgbClr val="008AC8"/>
-                </a:solidFill>
-              </a:rPr>
-              <a:t>SimReady validator (standalone)</a:t>
-            </a:r>
-          </a:p>
-        </p:txBody>
-      </p:sp>
-      <p:sp>
-        <p:nvSpPr>
-          <p:cNvPr id="73" name="Rectangle 72"/>
-          <p:cNvSpPr/>
-          <p:nvPr/>
-        </p:nvSpPr>
-        <p:spPr>
-          <a:xfrm>
-            <a:off x="10134599" y="4242816"/>
-            <a:ext cx="1798320" cy="384048"/>
-          </a:xfrm>
-          <a:prstGeom prst="rect">
-            <a:avLst/>
-          </a:prstGeom>
-          <a:solidFill>
-            <a:srgbClr val="16213E"/>
-          </a:solidFill>
-          <a:ln w="19050">
-            <a:solidFill>
-              <a:srgbClr val="008AC8"/>
-            </a:solidFill>
-          </a:ln>
-        </p:spPr>
-        <p:style>
-          <a:lnRef idx="1">
-            <a:schemeClr val="accent1"/>
-          </a:lnRef>
-          <a:fillRef idx="3">
-            <a:schemeClr val="accent1"/>
-          </a:fillRef>
-          <a:effectRef idx="2">
-            <a:schemeClr val="accent1"/>
-          </a:effectRef>
-          <a:fontRef idx="minor">
-            <a:schemeClr val="lt1"/>
-          </a:fontRef>
-        </p:style>
-        <p:txBody>
-          <a:bodyPr rtlCol="0" anchor="ctr"/>
-          <a:lstStyle/>
-          <a:p>
-            <a:pPr algn="ctr"/>
-          </a:p>
-        </p:txBody>
-      </p:sp>
-      <p:sp>
-        <p:nvSpPr>
-          <p:cNvPr id="74" name="TextBox 73"/>
-          <p:cNvSpPr txBox="1"/>
-          <p:nvPr/>
-        </p:nvSpPr>
-        <p:spPr>
-          <a:xfrm>
-            <a:off x="10152887" y="4261104"/>
-            <a:ext cx="1780032" cy="347472"/>
-          </a:xfrm>
-          <a:prstGeom prst="rect">
-            <a:avLst/>
-          </a:prstGeom>
-          <a:noFill/>
-        </p:spPr>
-        <p:txBody>
-          <a:bodyPr wrap="square">
-            <a:spAutoFit/>
-          </a:bodyPr>
-          <a:lstStyle/>
-          <a:p>
-            <a:pPr algn="ctr"/>
-            <a:r>
-              <a:rPr sz="700" b="0">
-                <a:solidFill>
-                  <a:srgbClr val="008AC8"/>
-                </a:solidFill>
-              </a:rPr>
-              <a:t>ovRTX render validation</a:t>
-            </a:r>
-          </a:p>
-        </p:txBody>
-      </p:sp>
-      <p:sp>
-        <p:nvSpPr>
-          <p:cNvPr id="75" name="Rectangle 74"/>
-          <p:cNvSpPr/>
-          <p:nvPr/>
-        </p:nvSpPr>
-        <p:spPr>
-          <a:xfrm>
-            <a:off x="10134599" y="4681728"/>
-            <a:ext cx="1798320" cy="384048"/>
-          </a:xfrm>
-          <a:prstGeom prst="rect">
-            <a:avLst/>
-          </a:prstGeom>
-          <a:solidFill>
-            <a:srgbClr val="16213E"/>
-          </a:solidFill>
-          <a:ln w="19050">
-            <a:solidFill>
-              <a:srgbClr val="E58C1A"/>
-            </a:solidFill>
-          </a:ln>
-        </p:spPr>
-        <p:style>
-          <a:lnRef idx="1">
-            <a:schemeClr val="accent1"/>
-          </a:lnRef>
-          <a:fillRef idx="3">
-            <a:schemeClr val="accent1"/>
-          </a:fillRef>
-          <a:effectRef idx="2">
-            <a:schemeClr val="accent1"/>
-          </a:effectRef>
-          <a:fontRef idx="minor">
-            <a:schemeClr val="lt1"/>
-          </a:fontRef>
-        </p:style>
-        <p:txBody>
-          <a:bodyPr rtlCol="0" anchor="ctr"/>
-          <a:lstStyle/>
-          <a:p>
-            <a:pPr algn="ctr"/>
-          </a:p>
-        </p:txBody>
-      </p:sp>
-      <p:sp>
-        <p:nvSpPr>
-          <p:cNvPr id="76" name="TextBox 75"/>
-          <p:cNvSpPr txBox="1"/>
-          <p:nvPr/>
-        </p:nvSpPr>
-        <p:spPr>
-          <a:xfrm>
-            <a:off x="10152887" y="4700016"/>
-            <a:ext cx="1780032" cy="347472"/>
-          </a:xfrm>
-          <a:prstGeom prst="rect">
-            <a:avLst/>
-          </a:prstGeom>
-          <a:noFill/>
-        </p:spPr>
-        <p:txBody>
-          <a:bodyPr wrap="square">
-            <a:spAutoFit/>
-          </a:bodyPr>
-          <a:lstStyle/>
-          <a:p>
-            <a:pPr algn="ctr"/>
-            <a:r>
-              <a:rPr sz="700" b="0">
-                <a:solidFill>
-                  <a:srgbClr val="E58C1A"/>
-                </a:solidFill>
-              </a:rPr>
-              <a:t>Siemens DTC export adapter</a:t>
-            </a:r>
-          </a:p>
-        </p:txBody>
-      </p:sp>
-      <p:sp>
-        <p:nvSpPr>
-          <p:cNvPr id="77" name="Rectangle 76"/>
-          <p:cNvSpPr/>
-          <p:nvPr/>
-        </p:nvSpPr>
-        <p:spPr>
-          <a:xfrm>
-            <a:off x="10134599" y="5120640"/>
-            <a:ext cx="1798320" cy="384048"/>
-          </a:xfrm>
-          <a:prstGeom prst="rect">
-            <a:avLst/>
-          </a:prstGeom>
-          <a:solidFill>
-            <a:srgbClr val="16213E"/>
-          </a:solidFill>
-          <a:ln w="19050">
-            <a:solidFill>
-              <a:srgbClr val="F5C518"/>
-            </a:solidFill>
-          </a:ln>
-        </p:spPr>
-        <p:style>
-          <a:lnRef idx="1">
-            <a:schemeClr val="accent1"/>
-          </a:lnRef>
-          <a:fillRef idx="3">
-            <a:schemeClr val="accent1"/>
-          </a:fillRef>
-          <a:effectRef idx="2">
-            <a:schemeClr val="accent1"/>
-          </a:effectRef>
-          <a:fontRef idx="minor">
-            <a:schemeClr val="lt1"/>
-          </a:fontRef>
-        </p:style>
-        <p:txBody>
-          <a:bodyPr rtlCol="0" anchor="ctr"/>
-          <a:lstStyle/>
-          <a:p>
-            <a:pPr algn="ctr"/>
-          </a:p>
-        </p:txBody>
-      </p:sp>
-      <p:sp>
-        <p:nvSpPr>
-          <p:cNvPr id="78" name="TextBox 77"/>
-          <p:cNvSpPr txBox="1"/>
-          <p:nvPr/>
-        </p:nvSpPr>
-        <p:spPr>
-          <a:xfrm>
-            <a:off x="10152887" y="5138928"/>
-            <a:ext cx="1780032" cy="347472"/>
-          </a:xfrm>
-          <a:prstGeom prst="rect">
-            <a:avLst/>
-          </a:prstGeom>
-          <a:noFill/>
-        </p:spPr>
-        <p:txBody>
-          <a:bodyPr wrap="square">
-            <a:spAutoFit/>
-          </a:bodyPr>
-          <a:lstStyle/>
-          <a:p>
-            <a:pPr algn="ctr"/>
-            <a:r>
-              <a:rPr sz="700" b="0">
-                <a:solidFill>
-                  <a:srgbClr val="F5C518"/>
-                </a:solidFill>
-              </a:rPr>
-              <a:t>USD output writer sample</a:t>
-            </a:r>
-          </a:p>
-        </p:txBody>
-      </p:sp>
-      <p:sp>
-        <p:nvSpPr>
-          <p:cNvPr id="79" name="TextBox 78"/>
-          <p:cNvSpPr txBox="1"/>
-          <p:nvPr/>
-        </p:nvSpPr>
-        <p:spPr>
-          <a:xfrm>
-            <a:off x="182880" y="6400800"/>
-            <a:ext cx="731520" cy="320040"/>
-          </a:xfrm>
-          <a:prstGeom prst="rect">
-            <a:avLst/>
-          </a:prstGeom>
-          <a:noFill/>
-        </p:spPr>
-        <p:txBody>
-          <a:bodyPr wrap="square">
-            <a:spAutoFit/>
-          </a:bodyPr>
-          <a:lstStyle/>
-          <a:p>
-            <a:pPr algn="l"/>
-            <a:r>
-              <a:rPr sz="900" b="1">
-                <a:solidFill>
-                  <a:srgbClr val="AAAAAA"/>
-                </a:solidFill>
-              </a:rPr>
-              <a:t>Legend:</a:t>
-            </a:r>
-          </a:p>
-        </p:txBody>
-      </p:sp>
-      <p:sp>
-        <p:nvSpPr>
-          <p:cNvPr id="80" name="Rectangle 79"/>
-          <p:cNvSpPr/>
-          <p:nvPr/>
-        </p:nvSpPr>
-        <p:spPr>
-          <a:xfrm>
-            <a:off x="914400" y="6400800"/>
-            <a:ext cx="1554480" cy="274320"/>
-          </a:xfrm>
-          <a:prstGeom prst="rect">
-            <a:avLst/>
-          </a:prstGeom>
-          <a:solidFill>
-            <a:srgbClr val="16213E"/>
-          </a:solidFill>
-          <a:ln w="19050">
-            <a:solidFill>
-              <a:srgbClr val="008AC8"/>
-            </a:solidFill>
-          </a:ln>
-        </p:spPr>
-        <p:style>
-          <a:lnRef idx="1">
-            <a:schemeClr val="accent1"/>
-          </a:lnRef>
-          <a:fillRef idx="3">
-            <a:schemeClr val="accent1"/>
-          </a:fillRef>
-          <a:effectRef idx="2">
-            <a:schemeClr val="accent1"/>
-          </a:effectRef>
-          <a:fontRef idx="minor">
-            <a:schemeClr val="lt1"/>
-          </a:fontRef>
-        </p:style>
-        <p:txBody>
-          <a:bodyPr rtlCol="0" anchor="ctr"/>
-          <a:lstStyle/>
-          <a:p>
-            <a:pPr algn="ctr"/>
-          </a:p>
-        </p:txBody>
-      </p:sp>
-      <p:sp>
-        <p:nvSpPr>
-          <p:cNvPr id="81" name="TextBox 80"/>
-          <p:cNvSpPr txBox="1"/>
-          <p:nvPr/>
-        </p:nvSpPr>
-        <p:spPr>
-          <a:xfrm>
-            <a:off x="960120" y="6419088"/>
-            <a:ext cx="1463040" cy="237744"/>
-          </a:xfrm>
-          <a:prstGeom prst="rect">
-            <a:avLst/>
-          </a:prstGeom>
-          <a:noFill/>
-        </p:spPr>
-        <p:txBody>
-          <a:bodyPr wrap="square">
-            <a:spAutoFit/>
-          </a:bodyPr>
-          <a:lstStyle/>
-          <a:p>
-            <a:pPr algn="ctr"/>
-            <a:r>
-              <a:rPr sz="800" b="1">
-                <a:solidFill>
-                  <a:srgbClr val="008AC8"/>
-                </a:solidFill>
-              </a:rPr>
-              <a:t>🔵  NVIDIA</a:t>
-            </a:r>
-          </a:p>
-        </p:txBody>
-      </p:sp>
-      <p:sp>
-        <p:nvSpPr>
-          <p:cNvPr id="82" name="Rectangle 81"/>
-          <p:cNvSpPr/>
-          <p:nvPr/>
-        </p:nvSpPr>
-        <p:spPr>
-          <a:xfrm>
-            <a:off x="2743200" y="6400800"/>
-            <a:ext cx="1554480" cy="274320"/>
-          </a:xfrm>
-          <a:prstGeom prst="rect">
-            <a:avLst/>
-          </a:prstGeom>
-          <a:solidFill>
-            <a:srgbClr val="16213E"/>
-          </a:solidFill>
-          <a:ln w="19050">
-            <a:solidFill>
-              <a:srgbClr val="E54B4B"/>
-            </a:solidFill>
-          </a:ln>
-        </p:spPr>
-        <p:style>
-          <a:lnRef idx="1">
-            <a:schemeClr val="accent1"/>
-          </a:lnRef>
-          <a:fillRef idx="3">
-            <a:schemeClr val="accent1"/>
-          </a:fillRef>
-          <a:effectRef idx="2">
-            <a:schemeClr val="accent1"/>
-          </a:effectRef>
-          <a:fontRef idx="minor">
-            <a:schemeClr val="lt1"/>
-          </a:fontRef>
-        </p:style>
-        <p:txBody>
-          <a:bodyPr rtlCol="0" anchor="ctr"/>
-          <a:lstStyle/>
-          <a:p>
-            <a:pPr algn="ctr"/>
-          </a:p>
-        </p:txBody>
-      </p:sp>
-      <p:sp>
-        <p:nvSpPr>
-          <p:cNvPr id="83" name="TextBox 82"/>
-          <p:cNvSpPr txBox="1"/>
-          <p:nvPr/>
-        </p:nvSpPr>
-        <p:spPr>
-          <a:xfrm>
-            <a:off x="2788920" y="6419088"/>
-            <a:ext cx="1463040" cy="237744"/>
-          </a:xfrm>
-          <a:prstGeom prst="rect">
-            <a:avLst/>
-          </a:prstGeom>
-          <a:noFill/>
-        </p:spPr>
-        <p:txBody>
-          <a:bodyPr wrap="square">
-            <a:spAutoFit/>
-          </a:bodyPr>
-          <a:lstStyle/>
-          <a:p>
-            <a:pPr algn="ctr"/>
-            <a:r>
-              <a:rPr sz="800" b="1">
-                <a:solidFill>
-                  <a:srgbClr val="E54B4B"/>
-                </a:solidFill>
-              </a:rPr>
-              <a:t>🔴  Physna</a:t>
-            </a:r>
-          </a:p>
-        </p:txBody>
-      </p:sp>
-      <p:sp>
-        <p:nvSpPr>
-          <p:cNvPr id="84" name="Rectangle 83"/>
-          <p:cNvSpPr/>
-          <p:nvPr/>
-        </p:nvSpPr>
-        <p:spPr>
-          <a:xfrm>
-            <a:off x="4572000" y="6400800"/>
-            <a:ext cx="1554480" cy="274320"/>
-          </a:xfrm>
-          <a:prstGeom prst="rect">
-            <a:avLst/>
-          </a:prstGeom>
-          <a:solidFill>
-            <a:srgbClr val="16213E"/>
-          </a:solidFill>
-          <a:ln w="19050">
-            <a:solidFill>
-              <a:srgbClr val="E58C1A"/>
-            </a:solidFill>
-          </a:ln>
-        </p:spPr>
-        <p:style>
-          <a:lnRef idx="1">
-            <a:schemeClr val="accent1"/>
-          </a:lnRef>
-          <a:fillRef idx="3">
-            <a:schemeClr val="accent1"/>
-          </a:fillRef>
-          <a:effectRef idx="2">
-            <a:schemeClr val="accent1"/>
-          </a:effectRef>
-          <a:fontRef idx="minor">
-            <a:schemeClr val="lt1"/>
-          </a:fontRef>
-        </p:style>
-        <p:txBody>
-          <a:bodyPr rtlCol="0" anchor="ctr"/>
-          <a:lstStyle/>
-          <a:p>
-            <a:pPr algn="ctr"/>
-          </a:p>
-        </p:txBody>
-      </p:sp>
-      <p:sp>
-        <p:nvSpPr>
-          <p:cNvPr id="85" name="TextBox 84"/>
-          <p:cNvSpPr txBox="1"/>
-          <p:nvPr/>
-        </p:nvSpPr>
-        <p:spPr>
-          <a:xfrm>
-            <a:off x="4617720" y="6419088"/>
-            <a:ext cx="1463040" cy="237744"/>
-          </a:xfrm>
-          <a:prstGeom prst="rect">
-            <a:avLst/>
-          </a:prstGeom>
-          <a:noFill/>
-        </p:spPr>
-        <p:txBody>
-          <a:bodyPr wrap="square">
-            <a:spAutoFit/>
-          </a:bodyPr>
-          <a:lstStyle/>
-          <a:p>
-            <a:pPr algn="ctr"/>
-            <a:r>
-              <a:rPr sz="800" b="1">
-                <a:solidFill>
-                  <a:srgbClr val="E58C1A"/>
-                </a:solidFill>
-              </a:rPr>
-              <a:t>🟠  Siemens</a:t>
-            </a:r>
-          </a:p>
-        </p:txBody>
-      </p:sp>
-      <p:sp>
-        <p:nvSpPr>
-          <p:cNvPr id="86" name="Rectangle 85"/>
-          <p:cNvSpPr/>
-          <p:nvPr/>
-        </p:nvSpPr>
-        <p:spPr>
-          <a:xfrm>
-            <a:off x="6400800" y="6400800"/>
-            <a:ext cx="1554480" cy="274320"/>
-          </a:xfrm>
-          <a:prstGeom prst="rect">
-            <a:avLst/>
-          </a:prstGeom>
-          <a:solidFill>
-            <a:srgbClr val="16213E"/>
-          </a:solidFill>
-          <a:ln w="19050">
-            <a:solidFill>
-              <a:srgbClr val="4CAF50"/>
-            </a:solidFill>
-          </a:ln>
-        </p:spPr>
-        <p:style>
-          <a:lnRef idx="1">
-            <a:schemeClr val="accent1"/>
-          </a:lnRef>
-          <a:fillRef idx="3">
-            <a:schemeClr val="accent1"/>
-          </a:fillRef>
-          <a:effectRef idx="2">
-            <a:schemeClr val="accent1"/>
-          </a:effectRef>
-          <a:fontRef idx="minor">
-            <a:schemeClr val="lt1"/>
-          </a:fontRef>
-        </p:style>
-        <p:txBody>
-          <a:bodyPr rtlCol="0" anchor="ctr"/>
-          <a:lstStyle/>
-          <a:p>
-            <a:pPr algn="ctr"/>
-          </a:p>
-        </p:txBody>
-      </p:sp>
-      <p:sp>
-        <p:nvSpPr>
           <p:cNvPr id="87" name="TextBox 86"/>
           <p:cNvSpPr txBox="1"/>
           <p:nvPr/>
@@ -7065,10 +7065,10 @@
             <a:r>
               <a:rPr sz="800" b="1">
                 <a:solidFill>
-                  <a:srgbClr val="4CAF50"/>
-                </a:solidFill>
-              </a:rPr>
-              <a:t>🟢  OSS</a:t>
+                  <a:srgbClr val="008AC8"/>
+                </a:solidFill>
+              </a:rPr>
+              <a:t>🔵  OSS</a:t>
             </a:r>
           </a:p>
         </p:txBody>
@@ -8634,7 +8634,7 @@
           </a:solidFill>
           <a:ln w="19050">
             <a:solidFill>
-              <a:srgbClr val="4CAF50"/>
+              <a:srgbClr val="008AC8"/>
             </a:solidFill>
           </a:ln>
         </p:spPr>
@@ -8686,7 +8686,7 @@
             <a:r>
               <a:rPr sz="1200" b="1">
                 <a:solidFill>
-                  <a:srgbClr val="4CAF50"/>
+                  <a:srgbClr val="008AC8"/>
                 </a:solidFill>
               </a:rPr>
               <a:t>Example: Swapping Segmentation Algorithm</a:t>
@@ -9191,7 +9191,7 @@
           </a:solidFill>
           <a:ln w="25400">
             <a:solidFill>
-              <a:srgbClr val="008AC8"/>
+              <a:srgbClr val="76B900"/>
             </a:solidFill>
           </a:ln>
         </p:spPr>
@@ -9243,7 +9243,7 @@
             <a:r>
               <a:rPr sz="1000" b="1">
                 <a:solidFill>
-                  <a:srgbClr val="008AC8"/>
+                  <a:srgbClr val="76B900"/>
                 </a:solidFill>
               </a:rPr>
               <a:t>🔵  NVIDIA</a:t>
@@ -9941,7 +9941,7 @@
           </a:solidFill>
           <a:ln w="25400">
             <a:solidFill>
-              <a:srgbClr val="4CAF50"/>
+              <a:srgbClr val="008AC8"/>
             </a:solidFill>
           </a:ln>
         </p:spPr>
@@ -9993,7 +9993,7 @@
             <a:r>
               <a:rPr sz="1000" b="1">
                 <a:solidFill>
-                  <a:srgbClr val="4CAF50"/>
+                  <a:srgbClr val="008AC8"/>
                 </a:solidFill>
               </a:rPr>
               <a:t>🟢  OSS</a:t>
@@ -10938,7 +10938,7 @@
           </a:solidFill>
           <a:ln w="25400">
             <a:solidFill>
-              <a:srgbClr val="4CAF50"/>
+              <a:srgbClr val="008AC8"/>
             </a:solidFill>
           </a:ln>
         </p:spPr>
@@ -10973,197 +10973,6 @@
         <p:spPr>
           <a:xfrm>
             <a:off x="274320" y="2423160"/>
-            <a:ext cx="502920" cy="1188720"/>
-          </a:xfrm>
-          <a:prstGeom prst="rect">
-            <a:avLst/>
-          </a:prstGeom>
-          <a:solidFill>
-            <a:srgbClr val="4CAF50"/>
-          </a:solidFill>
-          <a:ln w="12700">
-            <a:noFill/>
-          </a:ln>
-        </p:spPr>
-        <p:style>
-          <a:lnRef idx="1">
-            <a:schemeClr val="accent1"/>
-          </a:lnRef>
-          <a:fillRef idx="3">
-            <a:schemeClr val="accent1"/>
-          </a:fillRef>
-          <a:effectRef idx="2">
-            <a:schemeClr val="accent1"/>
-          </a:effectRef>
-          <a:fontRef idx="minor">
-            <a:schemeClr val="lt1"/>
-          </a:fontRef>
-        </p:style>
-        <p:txBody>
-          <a:bodyPr rtlCol="0" anchor="ctr"/>
-          <a:lstStyle/>
-          <a:p>
-            <a:pPr algn="ctr"/>
-          </a:p>
-        </p:txBody>
-      </p:sp>
-      <p:sp>
-        <p:nvSpPr>
-          <p:cNvPr id="13" name="TextBox 12"/>
-          <p:cNvSpPr txBox="1"/>
-          <p:nvPr/>
-        </p:nvSpPr>
-        <p:spPr>
-          <a:xfrm>
-            <a:off x="274320" y="2743200"/>
-            <a:ext cx="502920" cy="457200"/>
-          </a:xfrm>
-          <a:prstGeom prst="rect">
-            <a:avLst/>
-          </a:prstGeom>
-          <a:noFill/>
-        </p:spPr>
-        <p:txBody>
-          <a:bodyPr wrap="square">
-            <a:spAutoFit/>
-          </a:bodyPr>
-          <a:lstStyle/>
-          <a:p>
-            <a:pPr algn="ctr"/>
-            <a:r>
-              <a:rPr sz="2200" b="1">
-                <a:solidFill>
-                  <a:srgbClr val="FFFFFF"/>
-                </a:solidFill>
-              </a:rPr>
-              <a:t>2</a:t>
-            </a:r>
-          </a:p>
-        </p:txBody>
-      </p:sp>
-      <p:sp>
-        <p:nvSpPr>
-          <p:cNvPr id="14" name="TextBox 13"/>
-          <p:cNvSpPr txBox="1"/>
-          <p:nvPr/>
-        </p:nvSpPr>
-        <p:spPr>
-          <a:xfrm>
-            <a:off x="914400" y="2496312"/>
-            <a:ext cx="10789920" cy="320040"/>
-          </a:xfrm>
-          <a:prstGeom prst="rect">
-            <a:avLst/>
-          </a:prstGeom>
-          <a:noFill/>
-        </p:spPr>
-        <p:txBody>
-          <a:bodyPr wrap="square">
-            <a:spAutoFit/>
-          </a:bodyPr>
-          <a:lstStyle/>
-          <a:p>
-            <a:pPr algn="l"/>
-            <a:r>
-              <a:rPr sz="1300" b="1">
-                <a:solidFill>
-                  <a:srgbClr val="4CAF50"/>
-                </a:solidFill>
-              </a:rPr>
-              <a:t>Segmentation fidelity at EA</a:t>
-            </a:r>
-          </a:p>
-        </p:txBody>
-      </p:sp>
-      <p:sp>
-        <p:nvSpPr>
-          <p:cNvPr id="15" name="TextBox 14"/>
-          <p:cNvSpPr txBox="1"/>
-          <p:nvPr/>
-        </p:nvSpPr>
-        <p:spPr>
-          <a:xfrm>
-            <a:off x="914400" y="2834640"/>
-            <a:ext cx="10789920" cy="685800"/>
-          </a:xfrm>
-          <a:prstGeom prst="rect">
-            <a:avLst/>
-          </a:prstGeom>
-          <a:noFill/>
-        </p:spPr>
-        <p:txBody>
-          <a:bodyPr wrap="square">
-            <a:spAutoFit/>
-          </a:bodyPr>
-          <a:lstStyle/>
-          <a:p>
-            <a:pPr algn="l"/>
-            <a:r>
-              <a:rPr sz="1000" b="0">
-                <a:solidFill>
-                  <a:srgbClr val="AAAAAA"/>
-                </a:solidFill>
-              </a:rPr>
-              <a:t>Is open3d Euclidean cluster segmentation sufficient for factory floor objects at EA?
-Or do we need to scope a DL model (post-EA)?</a:t>
-            </a:r>
-          </a:p>
-        </p:txBody>
-      </p:sp>
-      <p:sp>
-        <p:nvSpPr>
-          <p:cNvPr id="16" name="Rectangle 15"/>
-          <p:cNvSpPr/>
-          <p:nvPr/>
-        </p:nvSpPr>
-        <p:spPr>
-          <a:xfrm>
-            <a:off x="274320" y="3794760"/>
-            <a:ext cx="11612880" cy="1188720"/>
-          </a:xfrm>
-          <a:prstGeom prst="rect">
-            <a:avLst/>
-          </a:prstGeom>
-          <a:solidFill>
-            <a:srgbClr val="16213E"/>
-          </a:solidFill>
-          <a:ln w="25400">
-            <a:solidFill>
-              <a:srgbClr val="008AC8"/>
-            </a:solidFill>
-          </a:ln>
-        </p:spPr>
-        <p:style>
-          <a:lnRef idx="1">
-            <a:schemeClr val="accent1"/>
-          </a:lnRef>
-          <a:fillRef idx="3">
-            <a:schemeClr val="accent1"/>
-          </a:fillRef>
-          <a:effectRef idx="2">
-            <a:schemeClr val="accent1"/>
-          </a:effectRef>
-          <a:fontRef idx="minor">
-            <a:schemeClr val="lt1"/>
-          </a:fontRef>
-        </p:style>
-        <p:txBody>
-          <a:bodyPr rtlCol="0" anchor="ctr"/>
-          <a:lstStyle/>
-          <a:p>
-            <a:pPr algn="ctr"/>
-          </a:p>
-        </p:txBody>
-      </p:sp>
-      <p:sp>
-        <p:nvSpPr>
-          <p:cNvPr id="17" name="Rectangle 16"/>
-          <p:cNvSpPr/>
-          <p:nvPr/>
-        </p:nvSpPr>
-        <p:spPr>
-          <a:xfrm>
-            <a:off x="274320" y="3794760"/>
             <a:ext cx="502920" cy="1188720"/>
           </a:xfrm>
           <a:prstGeom prst="rect">
@@ -11200,6 +11009,197 @@
       </p:sp>
       <p:sp>
         <p:nvSpPr>
+          <p:cNvPr id="13" name="TextBox 12"/>
+          <p:cNvSpPr txBox="1"/>
+          <p:nvPr/>
+        </p:nvSpPr>
+        <p:spPr>
+          <a:xfrm>
+            <a:off x="274320" y="2743200"/>
+            <a:ext cx="502920" cy="457200"/>
+          </a:xfrm>
+          <a:prstGeom prst="rect">
+            <a:avLst/>
+          </a:prstGeom>
+          <a:noFill/>
+        </p:spPr>
+        <p:txBody>
+          <a:bodyPr wrap="square">
+            <a:spAutoFit/>
+          </a:bodyPr>
+          <a:lstStyle/>
+          <a:p>
+            <a:pPr algn="ctr"/>
+            <a:r>
+              <a:rPr sz="2200" b="1">
+                <a:solidFill>
+                  <a:srgbClr val="FFFFFF"/>
+                </a:solidFill>
+              </a:rPr>
+              <a:t>2</a:t>
+            </a:r>
+          </a:p>
+        </p:txBody>
+      </p:sp>
+      <p:sp>
+        <p:nvSpPr>
+          <p:cNvPr id="14" name="TextBox 13"/>
+          <p:cNvSpPr txBox="1"/>
+          <p:nvPr/>
+        </p:nvSpPr>
+        <p:spPr>
+          <a:xfrm>
+            <a:off x="914400" y="2496312"/>
+            <a:ext cx="10789920" cy="320040"/>
+          </a:xfrm>
+          <a:prstGeom prst="rect">
+            <a:avLst/>
+          </a:prstGeom>
+          <a:noFill/>
+        </p:spPr>
+        <p:txBody>
+          <a:bodyPr wrap="square">
+            <a:spAutoFit/>
+          </a:bodyPr>
+          <a:lstStyle/>
+          <a:p>
+            <a:pPr algn="l"/>
+            <a:r>
+              <a:rPr sz="1300" b="1">
+                <a:solidFill>
+                  <a:srgbClr val="008AC8"/>
+                </a:solidFill>
+              </a:rPr>
+              <a:t>Segmentation fidelity at EA</a:t>
+            </a:r>
+          </a:p>
+        </p:txBody>
+      </p:sp>
+      <p:sp>
+        <p:nvSpPr>
+          <p:cNvPr id="15" name="TextBox 14"/>
+          <p:cNvSpPr txBox="1"/>
+          <p:nvPr/>
+        </p:nvSpPr>
+        <p:spPr>
+          <a:xfrm>
+            <a:off x="914400" y="2834640"/>
+            <a:ext cx="10789920" cy="685800"/>
+          </a:xfrm>
+          <a:prstGeom prst="rect">
+            <a:avLst/>
+          </a:prstGeom>
+          <a:noFill/>
+        </p:spPr>
+        <p:txBody>
+          <a:bodyPr wrap="square">
+            <a:spAutoFit/>
+          </a:bodyPr>
+          <a:lstStyle/>
+          <a:p>
+            <a:pPr algn="l"/>
+            <a:r>
+              <a:rPr sz="1000" b="0">
+                <a:solidFill>
+                  <a:srgbClr val="AAAAAA"/>
+                </a:solidFill>
+              </a:rPr>
+              <a:t>Is open3d Euclidean cluster segmentation sufficient for factory floor objects at EA?
+Or do we need to scope a DL model (post-EA)?</a:t>
+            </a:r>
+          </a:p>
+        </p:txBody>
+      </p:sp>
+      <p:sp>
+        <p:nvSpPr>
+          <p:cNvPr id="16" name="Rectangle 15"/>
+          <p:cNvSpPr/>
+          <p:nvPr/>
+        </p:nvSpPr>
+        <p:spPr>
+          <a:xfrm>
+            <a:off x="274320" y="3794760"/>
+            <a:ext cx="11612880" cy="1188720"/>
+          </a:xfrm>
+          <a:prstGeom prst="rect">
+            <a:avLst/>
+          </a:prstGeom>
+          <a:solidFill>
+            <a:srgbClr val="16213E"/>
+          </a:solidFill>
+          <a:ln w="25400">
+            <a:solidFill>
+              <a:srgbClr val="76B900"/>
+            </a:solidFill>
+          </a:ln>
+        </p:spPr>
+        <p:style>
+          <a:lnRef idx="1">
+            <a:schemeClr val="accent1"/>
+          </a:lnRef>
+          <a:fillRef idx="3">
+            <a:schemeClr val="accent1"/>
+          </a:fillRef>
+          <a:effectRef idx="2">
+            <a:schemeClr val="accent1"/>
+          </a:effectRef>
+          <a:fontRef idx="minor">
+            <a:schemeClr val="lt1"/>
+          </a:fontRef>
+        </p:style>
+        <p:txBody>
+          <a:bodyPr rtlCol="0" anchor="ctr"/>
+          <a:lstStyle/>
+          <a:p>
+            <a:pPr algn="ctr"/>
+          </a:p>
+        </p:txBody>
+      </p:sp>
+      <p:sp>
+        <p:nvSpPr>
+          <p:cNvPr id="17" name="Rectangle 16"/>
+          <p:cNvSpPr/>
+          <p:nvPr/>
+        </p:nvSpPr>
+        <p:spPr>
+          <a:xfrm>
+            <a:off x="274320" y="3794760"/>
+            <a:ext cx="502920" cy="1188720"/>
+          </a:xfrm>
+          <a:prstGeom prst="rect">
+            <a:avLst/>
+          </a:prstGeom>
+          <a:solidFill>
+            <a:srgbClr val="76B900"/>
+          </a:solidFill>
+          <a:ln w="12700">
+            <a:noFill/>
+          </a:ln>
+        </p:spPr>
+        <p:style>
+          <a:lnRef idx="1">
+            <a:schemeClr val="accent1"/>
+          </a:lnRef>
+          <a:fillRef idx="3">
+            <a:schemeClr val="accent1"/>
+          </a:fillRef>
+          <a:effectRef idx="2">
+            <a:schemeClr val="accent1"/>
+          </a:effectRef>
+          <a:fontRef idx="minor">
+            <a:schemeClr val="lt1"/>
+          </a:fontRef>
+        </p:style>
+        <p:txBody>
+          <a:bodyPr rtlCol="0" anchor="ctr"/>
+          <a:lstStyle/>
+          <a:p>
+            <a:pPr algn="ctr"/>
+          </a:p>
+        </p:txBody>
+      </p:sp>
+      <p:sp>
+        <p:nvSpPr>
           <p:cNvPr id="18" name="TextBox 17"/>
           <p:cNvSpPr txBox="1"/>
           <p:nvPr/>
@@ -11258,7 +11258,7 @@
             <a:r>
               <a:rPr sz="1300" b="1">
                 <a:solidFill>
-                  <a:srgbClr val="008AC8"/>
+                  <a:srgbClr val="76B900"/>
                 </a:solidFill>
               </a:rPr>
               <a:t>SimReady validator availability</a:t>

</xml_diff>